<commit_message>
change file paths and improve the pptx tf idf slides
</commit_message>
<xml_diff>
--- a/Lessons/L_Text_Mining_2/B_wordClouds_frequency.pptx
+++ b/Lessons/L_Text_Mining_2/B_wordClouds_frequency.pptx
@@ -5,7 +5,7 @@
     <p:sldMasterId id="2147483660" r:id="rId1"/>
   </p:sldMasterIdLst>
   <p:notesMasterIdLst>
-    <p:notesMasterId r:id="rId26"/>
+    <p:notesMasterId r:id="rId27"/>
   </p:notesMasterIdLst>
   <p:sldIdLst>
     <p:sldId id="778" r:id="rId2"/>
@@ -28,10 +28,11 @@
     <p:sldId id="793" r:id="rId19"/>
     <p:sldId id="794" r:id="rId20"/>
     <p:sldId id="797" r:id="rId21"/>
-    <p:sldId id="796" r:id="rId22"/>
-    <p:sldId id="795" r:id="rId23"/>
-    <p:sldId id="798" r:id="rId24"/>
-    <p:sldId id="791" r:id="rId25"/>
+    <p:sldId id="799" r:id="rId22"/>
+    <p:sldId id="796" r:id="rId23"/>
+    <p:sldId id="795" r:id="rId24"/>
+    <p:sldId id="798" r:id="rId25"/>
+    <p:sldId id="791" r:id="rId26"/>
   </p:sldIdLst>
   <p:sldSz cx="9144000" cy="6858000" type="screen4x3"/>
   <p:notesSz cx="7010400" cy="9296400"/>
@@ -231,7 +232,7 @@
           <a:p>
             <a:fld id="{B0C0A60C-850A-4EA4-9C14-A8FE98B94505}" type="datetimeFigureOut">
               <a:rPr lang="en-US" smtClean="0"/>
-              <a:t>4/28/25</a:t>
+              <a:t>4/20/26</a:t>
             </a:fld>
             <a:endParaRPr lang="en-US"/>
           </a:p>
@@ -726,7 +727,7 @@
           <a:p>
             <a:fld id="{5738B90E-0779-4C36-915C-6F05FCD89456}" type="datetime1">
               <a:rPr lang="en-US" smtClean="0"/>
-              <a:t>4/28/25</a:t>
+              <a:t>4/20/26</a:t>
             </a:fld>
             <a:endParaRPr lang="en-US"/>
           </a:p>
@@ -944,7 +945,7 @@
           <a:p>
             <a:fld id="{7B9EA29D-D431-42FE-B7B6-AAE4454C77D3}" type="datetime1">
               <a:rPr lang="en-US" smtClean="0"/>
-              <a:t>4/28/25</a:t>
+              <a:t>4/20/26</a:t>
             </a:fld>
             <a:endParaRPr lang="en-US"/>
           </a:p>
@@ -1204,7 +1205,7 @@
           <a:p>
             <a:fld id="{690D8A1E-EA8F-46C1-B891-AE0C00D9C314}" type="datetime1">
               <a:rPr lang="en-US" smtClean="0"/>
-              <a:t>4/28/25</a:t>
+              <a:t>4/20/26</a:t>
             </a:fld>
             <a:endParaRPr lang="en-US"/>
           </a:p>
@@ -1498,7 +1499,7 @@
           <a:p>
             <a:fld id="{D753EFC8-4232-4598-94F6-94C0EBAFC469}" type="datetime1">
               <a:rPr lang="en-US" smtClean="0"/>
-              <a:t>4/28/25</a:t>
+              <a:t>4/20/26</a:t>
             </a:fld>
             <a:endParaRPr lang="en-US"/>
           </a:p>
@@ -1813,7 +1814,7 @@
           <a:p>
             <a:fld id="{F3161074-1C18-4AE7-957D-F18524378C85}" type="datetime1">
               <a:rPr lang="en-US" smtClean="0"/>
-              <a:t>4/28/25</a:t>
+              <a:t>4/20/26</a:t>
             </a:fld>
             <a:endParaRPr lang="en-US"/>
           </a:p>
@@ -2087,7 +2088,7 @@
           <a:p>
             <a:fld id="{69BE256C-8D9A-4404-B47D-41A1AE514425}" type="datetime1">
               <a:rPr lang="en-US" smtClean="0"/>
-              <a:t>4/28/25</a:t>
+              <a:t>4/20/26</a:t>
             </a:fld>
             <a:endParaRPr lang="en-US"/>
           </a:p>
@@ -2521,7 +2522,7 @@
           <a:p>
             <a:fld id="{66CB2154-9035-4012-8189-BAAB61C5A5EE}" type="datetime1">
               <a:rPr lang="en-US" smtClean="0"/>
-              <a:t>4/28/25</a:t>
+              <a:t>4/20/26</a:t>
             </a:fld>
             <a:endParaRPr lang="en-US"/>
           </a:p>
@@ -2695,7 +2696,7 @@
           <a:p>
             <a:fld id="{6700A58B-DD98-43D0-B791-721480A02982}" type="datetime1">
               <a:rPr lang="en-US" smtClean="0"/>
-              <a:t>4/28/25</a:t>
+              <a:t>4/20/26</a:t>
             </a:fld>
             <a:endParaRPr lang="en-US"/>
           </a:p>
@@ -2887,7 +2888,7 @@
           <a:p>
             <a:fld id="{7DB6E382-4F61-4E24-BE1A-377EC83D0E3A}" type="datetime1">
               <a:rPr lang="en-US" smtClean="0"/>
-              <a:t>4/28/25</a:t>
+              <a:t>4/20/26</a:t>
             </a:fld>
             <a:endParaRPr lang="en-US"/>
           </a:p>
@@ -3198,7 +3199,7 @@
           <a:p>
             <a:fld id="{4142EED6-FC16-45B9-B8C4-2BC5DBA88325}" type="datetime1">
               <a:rPr lang="en-US" smtClean="0"/>
-              <a:t>4/28/25</a:t>
+              <a:t>4/20/26</a:t>
             </a:fld>
             <a:endParaRPr lang="en-US"/>
           </a:p>
@@ -3516,7 +3517,7 @@
           <a:p>
             <a:fld id="{DF59512B-4F1D-43D7-8819-2F53FEF69650}" type="datetime1">
               <a:rPr lang="en-US" smtClean="0"/>
-              <a:t>4/28/25</a:t>
+              <a:t>4/20/26</a:t>
             </a:fld>
             <a:endParaRPr lang="en-US"/>
           </a:p>
@@ -3792,7 +3793,7 @@
           <a:p>
             <a:fld id="{08437B94-E2BF-44DC-ADC5-B05FC9934E9D}" type="datetime1">
               <a:rPr lang="en-US" smtClean="0"/>
-              <a:t>4/28/25</a:t>
+              <a:t>4/20/26</a:t>
             </a:fld>
             <a:endParaRPr lang="en-US"/>
           </a:p>
@@ -4254,7 +4255,7 @@
             <a:fld id="{6700A58B-DD98-43D0-B791-721480A02982}" type="datetime1">
               <a:rPr lang="en-US" smtClean="0"/>
               <a:pPr/>
-              <a:t>4/28/25</a:t>
+              <a:t>4/20/26</a:t>
             </a:fld>
             <a:endParaRPr lang="en-US"/>
           </a:p>
@@ -4663,7 +4664,7 @@
             <a:fld id="{6700A58B-DD98-43D0-B791-721480A02982}" type="datetime1">
               <a:rPr lang="en-US" smtClean="0"/>
               <a:pPr/>
-              <a:t>4/28/25</a:t>
+              <a:t>4/20/26</a:t>
             </a:fld>
             <a:endParaRPr lang="en-US"/>
           </a:p>
@@ -5206,7 +5207,7 @@
             <a:fld id="{6700A58B-DD98-43D0-B791-721480A02982}" type="datetime1">
               <a:rPr lang="en-US" smtClean="0"/>
               <a:pPr/>
-              <a:t>4/28/25</a:t>
+              <a:t>4/20/26</a:t>
             </a:fld>
             <a:endParaRPr lang="en-US"/>
           </a:p>
@@ -6093,7 +6094,7 @@
             <a:fld id="{6700A58B-DD98-43D0-B791-721480A02982}" type="datetime1">
               <a:rPr lang="en-US" smtClean="0"/>
               <a:pPr/>
-              <a:t>4/28/25</a:t>
+              <a:t>4/20/26</a:t>
             </a:fld>
             <a:endParaRPr lang="en-US"/>
           </a:p>
@@ -7103,7 +7104,7 @@
             <a:fld id="{6700A58B-DD98-43D0-B791-721480A02982}" type="datetime1">
               <a:rPr lang="en-US" smtClean="0"/>
               <a:pPr/>
-              <a:t>4/28/25</a:t>
+              <a:t>4/20/26</a:t>
             </a:fld>
             <a:endParaRPr lang="en-US"/>
           </a:p>
@@ -8365,7 +8366,7 @@
             <a:fld id="{6700A58B-DD98-43D0-B791-721480A02982}" type="datetime1">
               <a:rPr lang="en-US" smtClean="0"/>
               <a:pPr/>
-              <a:t>4/28/25</a:t>
+              <a:t>4/20/26</a:t>
             </a:fld>
             <a:endParaRPr lang="en-US"/>
           </a:p>
@@ -8879,7 +8880,7 @@
             <a:fld id="{6700A58B-DD98-43D0-B791-721480A02982}" type="datetime1">
               <a:rPr lang="en-US" smtClean="0"/>
               <a:pPr/>
-              <a:t>4/28/25</a:t>
+              <a:t>4/20/26</a:t>
             </a:fld>
             <a:endParaRPr lang="en-US"/>
           </a:p>
@@ -9544,7 +9545,7 @@
           <a:p>
             <a:fld id="{6700A58B-DD98-43D0-B791-721480A02982}" type="datetime1">
               <a:rPr lang="en-US" smtClean="0"/>
-              <a:t>4/28/25</a:t>
+              <a:t>4/20/26</a:t>
             </a:fld>
             <a:endParaRPr lang="en-US"/>
           </a:p>
@@ -9775,7 +9776,7 @@
             <a:fld id="{6700A58B-DD98-43D0-B791-721480A02982}" type="datetime1">
               <a:rPr lang="en-US" smtClean="0"/>
               <a:pPr/>
-              <a:t>4/28/25</a:t>
+              <a:t>4/20/26</a:t>
             </a:fld>
             <a:endParaRPr lang="en-US"/>
           </a:p>
@@ -10760,7 +10761,7 @@
             <a:fld id="{6700A58B-DD98-43D0-B791-721480A02982}" type="datetime1">
               <a:rPr lang="en-US" smtClean="0"/>
               <a:pPr/>
-              <a:t>4/28/25</a:t>
+              <a:t>4/20/26</a:t>
             </a:fld>
             <a:endParaRPr lang="en-US"/>
           </a:p>
@@ -11162,7 +11163,7 @@
             <a:fld id="{6700A58B-DD98-43D0-B791-721480A02982}" type="datetime1">
               <a:rPr lang="en-US" smtClean="0"/>
               <a:pPr/>
-              <a:t>4/28/25</a:t>
+              <a:t>4/20/26</a:t>
             </a:fld>
             <a:endParaRPr lang="en-US"/>
           </a:p>
@@ -11431,7 +11432,7 @@
           <a:p>
             <a:r>
               <a:rPr lang="en-US" sz="2000" b="1" i="1" dirty="0"/>
-              <a:t>	log(total documents in corpus) / number of documents with term in it</a:t>
+              <a:t>	log(total documents in corpus / number of documents with term in it)</a:t>
             </a:r>
           </a:p>
         </p:txBody>
@@ -11688,7 +11689,7 @@
             <a:fld id="{6700A58B-DD98-43D0-B791-721480A02982}" type="datetime1">
               <a:rPr lang="en-US" smtClean="0"/>
               <a:pPr/>
-              <a:t>4/28/25</a:t>
+              <a:t>4/20/26</a:t>
             </a:fld>
             <a:endParaRPr lang="en-US"/>
           </a:p>
@@ -12225,7 +12226,7 @@
             <a:fld id="{6700A58B-DD98-43D0-B791-721480A02982}" type="datetime1">
               <a:rPr lang="en-US" smtClean="0"/>
               <a:pPr/>
-              <a:t>4/28/25</a:t>
+              <a:t>4/20/26</a:t>
             </a:fld>
             <a:endParaRPr lang="en-US"/>
           </a:p>
@@ -12247,10 +12248,22 @@
           <a:lstStyle/>
           <a:p>
             <a:r>
-              <a:rPr lang="en-US"/>
-              <a:t>Original Term Frequency</a:t>
-            </a:r>
-            <a:endParaRPr lang="en-US" dirty="0"/>
+              <a:rPr lang="en-US" dirty="0"/>
+              <a:t>Term Frequency </a:t>
+            </a:r>
+            <a:r>
+              <a:rPr lang="en-US" sz="2400" dirty="0">
+                <a:solidFill>
+                  <a:srgbClr val="FF0000"/>
+                </a:solidFill>
+              </a:rPr>
+              <a:t>[not quite frequency from before]</a:t>
+            </a:r>
+            <a:endParaRPr lang="en-US" dirty="0">
+              <a:solidFill>
+                <a:srgbClr val="FF0000"/>
+              </a:solidFill>
+            </a:endParaRPr>
           </a:p>
         </p:txBody>
       </p:sp>
@@ -12416,8 +12429,8 @@
         </p:nvSpPr>
         <p:spPr>
           <a:xfrm>
-            <a:off x="1585221" y="3059668"/>
-            <a:ext cx="5973558" cy="738664"/>
+            <a:off x="115754" y="3059668"/>
+            <a:ext cx="8912504" cy="1477328"/>
           </a:xfrm>
           <a:prstGeom prst="rect">
             <a:avLst/>
@@ -12433,7 +12446,7 @@
             <a:pPr algn="ctr"/>
             <a:r>
               <a:rPr lang="en-US" dirty="0"/>
-              <a:t>In 1000 documents suppose token “coffee” occurs 1000 times</a:t>
+              <a:t>In 1000 documents, each with 10 words suppose token “coffee” occurs 1 time per document.</a:t>
             </a:r>
             <a:endParaRPr lang="en-US" sz="2400" b="1" i="1" dirty="0"/>
           </a:p>
@@ -12441,7 +12454,21 @@
             <a:pPr algn="ctr"/>
             <a:r>
               <a:rPr lang="en-US" sz="2400" b="1" i="1" dirty="0"/>
-              <a:t>TF = 1000 </a:t>
+              <a:t>TF = 1 time in a document / 10 unique terms in a document</a:t>
+            </a:r>
+          </a:p>
+          <a:p>
+            <a:pPr algn="ctr"/>
+            <a:r>
+              <a:rPr lang="en-US" sz="2400" b="1" i="1" dirty="0"/>
+              <a:t>TF = 1/10</a:t>
+            </a:r>
+          </a:p>
+          <a:p>
+            <a:pPr algn="ctr"/>
+            <a:r>
+              <a:rPr lang="en-US" sz="2400" b="1" i="1" dirty="0"/>
+              <a:t>TF = 0.10</a:t>
             </a:r>
           </a:p>
         </p:txBody>
@@ -12532,6 +12559,41 @@
           </a:fontRef>
         </p:style>
       </p:cxnSp>
+      <p:sp>
+        <p:nvSpPr>
+          <p:cNvPr id="9" name="TextBox 8">
+            <a:extLst>
+              <a:ext uri="{FF2B5EF4-FFF2-40B4-BE49-F238E27FC236}">
+                <a16:creationId xmlns:a16="http://schemas.microsoft.com/office/drawing/2014/main" id="{6D98F603-7088-AE70-DDDA-6D58EFCABA7B}"/>
+              </a:ext>
+            </a:extLst>
+          </p:cNvPr>
+          <p:cNvSpPr txBox="1"/>
+          <p:nvPr/>
+        </p:nvSpPr>
+        <p:spPr>
+          <a:xfrm>
+            <a:off x="773941" y="1808080"/>
+            <a:ext cx="7596118" cy="400110"/>
+          </a:xfrm>
+          <a:prstGeom prst="rect">
+            <a:avLst/>
+          </a:prstGeom>
+          <a:noFill/>
+        </p:spPr>
+        <p:txBody>
+          <a:bodyPr wrap="none" rtlCol="0">
+            <a:spAutoFit/>
+          </a:bodyPr>
+          <a:lstStyle/>
+          <a:p>
+            <a:r>
+              <a:rPr lang="en-US" sz="2000" b="1" i="1" dirty="0"/>
+              <a:t>Term frequency = Term Occurrence / total unique terms in a document</a:t>
+            </a:r>
+          </a:p>
+        </p:txBody>
+      </p:sp>
     </p:spTree>
     <p:extLst>
       <p:ext uri="{BB962C8B-B14F-4D97-AF65-F5344CB8AC3E}">
@@ -12564,6 +12626,280 @@
       </p:grpSpPr>
       <p:sp>
         <p:nvSpPr>
+          <p:cNvPr id="2" name="Date Placeholder 1">
+            <a:extLst>
+              <a:ext uri="{FF2B5EF4-FFF2-40B4-BE49-F238E27FC236}">
+                <a16:creationId xmlns:a16="http://schemas.microsoft.com/office/drawing/2014/main" id="{63DC13A7-8EA5-0154-B126-72E8560C6427}"/>
+              </a:ext>
+            </a:extLst>
+          </p:cNvPr>
+          <p:cNvSpPr>
+            <a:spLocks noGrp="1"/>
+          </p:cNvSpPr>
+          <p:nvPr>
+            <p:ph type="dt" sz="half" idx="10"/>
+          </p:nvPr>
+        </p:nvSpPr>
+        <p:spPr/>
+        <p:txBody>
+          <a:bodyPr/>
+          <a:lstStyle/>
+          <a:p>
+            <a:fld id="{6700A58B-DD98-43D0-B791-721480A02982}" type="datetime1">
+              <a:rPr lang="en-US" smtClean="0"/>
+              <a:t>4/20/26</a:t>
+            </a:fld>
+            <a:endParaRPr lang="en-US"/>
+          </a:p>
+        </p:txBody>
+      </p:sp>
+      <p:sp>
+        <p:nvSpPr>
+          <p:cNvPr id="3" name="Title 2">
+            <a:extLst>
+              <a:ext uri="{FF2B5EF4-FFF2-40B4-BE49-F238E27FC236}">
+                <a16:creationId xmlns:a16="http://schemas.microsoft.com/office/drawing/2014/main" id="{E3A84406-C8AD-3AFF-1E2A-60AB1AC4CF12}"/>
+              </a:ext>
+            </a:extLst>
+          </p:cNvPr>
+          <p:cNvSpPr>
+            <a:spLocks noGrp="1"/>
+          </p:cNvSpPr>
+          <p:nvPr>
+            <p:ph type="title"/>
+          </p:nvPr>
+        </p:nvSpPr>
+        <p:spPr/>
+        <p:txBody>
+          <a:bodyPr/>
+          <a:lstStyle/>
+          <a:p>
+            <a:r>
+              <a:rPr lang="en-US" dirty="0"/>
+              <a:t>Inverse Document Frequency of TF-IDF</a:t>
+            </a:r>
+          </a:p>
+        </p:txBody>
+      </p:sp>
+      <p:sp>
+        <p:nvSpPr>
+          <p:cNvPr id="4" name="Slide Number Placeholder 3">
+            <a:extLst>
+              <a:ext uri="{FF2B5EF4-FFF2-40B4-BE49-F238E27FC236}">
+                <a16:creationId xmlns:a16="http://schemas.microsoft.com/office/drawing/2014/main" id="{6E8E51C6-73AD-92F5-8F6B-AE6813A2D2B2}"/>
+              </a:ext>
+            </a:extLst>
+          </p:cNvPr>
+          <p:cNvSpPr>
+            <a:spLocks noGrp="1"/>
+          </p:cNvSpPr>
+          <p:nvPr>
+            <p:ph type="sldNum" sz="quarter" idx="12"/>
+          </p:nvPr>
+        </p:nvSpPr>
+        <p:spPr/>
+        <p:txBody>
+          <a:bodyPr/>
+          <a:lstStyle/>
+          <a:p>
+            <a:fld id="{37290FF7-652B-4475-AEAB-8B1A5D23AE09}" type="slidenum">
+              <a:rPr lang="en-US" smtClean="0"/>
+              <a:t>21</a:t>
+            </a:fld>
+            <a:endParaRPr lang="en-US"/>
+          </a:p>
+        </p:txBody>
+      </p:sp>
+      <p:sp>
+        <p:nvSpPr>
+          <p:cNvPr id="5" name="Footer Placeholder 4">
+            <a:extLst>
+              <a:ext uri="{FF2B5EF4-FFF2-40B4-BE49-F238E27FC236}">
+                <a16:creationId xmlns:a16="http://schemas.microsoft.com/office/drawing/2014/main" id="{ABCEFEC4-3DA0-F702-3E1B-17074F457933}"/>
+              </a:ext>
+            </a:extLst>
+          </p:cNvPr>
+          <p:cNvSpPr>
+            <a:spLocks noGrp="1"/>
+          </p:cNvSpPr>
+          <p:nvPr>
+            <p:ph type="ftr" sz="quarter" idx="3"/>
+          </p:nvPr>
+        </p:nvSpPr>
+        <p:spPr/>
+        <p:txBody>
+          <a:bodyPr/>
+          <a:lstStyle/>
+          <a:p>
+            <a:r>
+              <a:rPr lang="en-US"/>
+              <a:t>Kwartler CSCI E-96</a:t>
+            </a:r>
+            <a:endParaRPr lang="en-US" dirty="0"/>
+          </a:p>
+        </p:txBody>
+      </p:sp>
+      <p:sp>
+        <p:nvSpPr>
+          <p:cNvPr id="6" name="TextBox 5">
+            <a:extLst>
+              <a:ext uri="{FF2B5EF4-FFF2-40B4-BE49-F238E27FC236}">
+                <a16:creationId xmlns:a16="http://schemas.microsoft.com/office/drawing/2014/main" id="{68C929FF-22F0-5CDE-3865-5DFAF7921BBD}"/>
+              </a:ext>
+            </a:extLst>
+          </p:cNvPr>
+          <p:cNvSpPr txBox="1"/>
+          <p:nvPr/>
+        </p:nvSpPr>
+        <p:spPr>
+          <a:xfrm>
+            <a:off x="237255" y="1874140"/>
+            <a:ext cx="8669489" cy="707886"/>
+          </a:xfrm>
+          <a:prstGeom prst="rect">
+            <a:avLst/>
+          </a:prstGeom>
+          <a:noFill/>
+        </p:spPr>
+        <p:txBody>
+          <a:bodyPr wrap="none" rtlCol="0">
+            <a:spAutoFit/>
+          </a:bodyPr>
+          <a:lstStyle/>
+          <a:p>
+            <a:r>
+              <a:rPr lang="en-US" sz="2000" b="1" i="1" dirty="0"/>
+              <a:t>Inverse Document Frequency = </a:t>
+            </a:r>
+          </a:p>
+          <a:p>
+            <a:r>
+              <a:rPr lang="en-US" sz="2000" b="1" i="1" dirty="0"/>
+              <a:t>	log(total documents in corpus / number of documents with term in it)</a:t>
+            </a:r>
+          </a:p>
+        </p:txBody>
+      </p:sp>
+      <p:sp>
+        <p:nvSpPr>
+          <p:cNvPr id="7" name="TextBox 6">
+            <a:extLst>
+              <a:ext uri="{FF2B5EF4-FFF2-40B4-BE49-F238E27FC236}">
+                <a16:creationId xmlns:a16="http://schemas.microsoft.com/office/drawing/2014/main" id="{00D9349E-8480-55F0-4719-270AF9E1082F}"/>
+              </a:ext>
+            </a:extLst>
+          </p:cNvPr>
+          <p:cNvSpPr txBox="1"/>
+          <p:nvPr/>
+        </p:nvSpPr>
+        <p:spPr>
+          <a:xfrm>
+            <a:off x="80577" y="3145620"/>
+            <a:ext cx="8982844" cy="707886"/>
+          </a:xfrm>
+          <a:prstGeom prst="rect">
+            <a:avLst/>
+          </a:prstGeom>
+          <a:noFill/>
+        </p:spPr>
+        <p:txBody>
+          <a:bodyPr wrap="none" rtlCol="0">
+            <a:spAutoFit/>
+          </a:bodyPr>
+          <a:lstStyle/>
+          <a:p>
+            <a:r>
+              <a:rPr lang="en-US" sz="2000" b="1" i="1" dirty="0"/>
+              <a:t>Since there are 1000 documents, and all 1000 have ”coffee”</a:t>
+            </a:r>
+          </a:p>
+          <a:p>
+            <a:r>
+              <a:rPr lang="en-US" sz="2000" b="1" i="1" dirty="0"/>
+              <a:t>	IDF = log(total documents in corpus / number of documents with term in it)</a:t>
+            </a:r>
+          </a:p>
+        </p:txBody>
+      </p:sp>
+      <p:sp>
+        <p:nvSpPr>
+          <p:cNvPr id="8" name="TextBox 7">
+            <a:extLst>
+              <a:ext uri="{FF2B5EF4-FFF2-40B4-BE49-F238E27FC236}">
+                <a16:creationId xmlns:a16="http://schemas.microsoft.com/office/drawing/2014/main" id="{1BDE412A-32BF-742A-38FC-6A1920688676}"/>
+              </a:ext>
+            </a:extLst>
+          </p:cNvPr>
+          <p:cNvSpPr txBox="1"/>
+          <p:nvPr/>
+        </p:nvSpPr>
+        <p:spPr>
+          <a:xfrm>
+            <a:off x="80577" y="3750083"/>
+            <a:ext cx="3398687" cy="1015663"/>
+          </a:xfrm>
+          <a:prstGeom prst="rect">
+            <a:avLst/>
+          </a:prstGeom>
+          <a:noFill/>
+        </p:spPr>
+        <p:txBody>
+          <a:bodyPr wrap="none" rtlCol="0">
+            <a:spAutoFit/>
+          </a:bodyPr>
+          <a:lstStyle/>
+          <a:p>
+            <a:r>
+              <a:rPr lang="en-US" sz="2000" b="1" i="1" dirty="0"/>
+              <a:t>	IDF = log(1000/ 1000)</a:t>
+            </a:r>
+          </a:p>
+          <a:p>
+            <a:r>
+              <a:rPr lang="en-US" sz="2000" b="1" i="1" dirty="0"/>
+              <a:t>	IDF = log(1)</a:t>
+            </a:r>
+          </a:p>
+          <a:p>
+            <a:r>
+              <a:rPr lang="en-US" sz="2000" b="1" i="1" dirty="0"/>
+              <a:t>	IDF = 0</a:t>
+            </a:r>
+          </a:p>
+        </p:txBody>
+      </p:sp>
+    </p:spTree>
+    <p:extLst>
+      <p:ext uri="{BB962C8B-B14F-4D97-AF65-F5344CB8AC3E}">
+        <p14:creationId xmlns:p14="http://schemas.microsoft.com/office/powerpoint/2010/main" val="1151606677"/>
+      </p:ext>
+    </p:extLst>
+  </p:cSld>
+  <p:clrMapOvr>
+    <a:masterClrMapping/>
+  </p:clrMapOvr>
+</p:sld>
+</file>
+
+<file path=ppt/slides/slide22.xml><?xml version="1.0" encoding="utf-8"?>
+<p:sld xmlns:a="http://schemas.openxmlformats.org/drawingml/2006/main" xmlns:r="http://schemas.openxmlformats.org/officeDocument/2006/relationships" xmlns:p="http://schemas.openxmlformats.org/presentationml/2006/main">
+  <p:cSld>
+    <p:spTree>
+      <p:nvGrpSpPr>
+        <p:cNvPr id="1" name=""/>
+        <p:cNvGrpSpPr/>
+        <p:nvPr/>
+      </p:nvGrpSpPr>
+      <p:grpSpPr>
+        <a:xfrm>
+          <a:off x="0" y="0"/>
+          <a:ext cx="0" cy="0"/>
+          <a:chOff x="0" y="0"/>
+          <a:chExt cx="0" cy="0"/>
+        </a:xfrm>
+      </p:grpSpPr>
+      <p:sp>
+        <p:nvSpPr>
           <p:cNvPr id="2" name="Date Placeholder 1"/>
           <p:cNvSpPr>
             <a:spLocks noGrp="1"/>
@@ -12580,7 +12916,7 @@
             <a:fld id="{6700A58B-DD98-43D0-B791-721480A02982}" type="datetime1">
               <a:rPr lang="en-US" smtClean="0"/>
               <a:pPr/>
-              <a:t>4/28/25</a:t>
+              <a:t>4/20/26</a:t>
             </a:fld>
             <a:endParaRPr lang="en-US"/>
           </a:p>
@@ -12757,7 +13093,7 @@
             <a:fld id="{37290FF7-652B-4475-AEAB-8B1A5D23AE09}" type="slidenum">
               <a:rPr lang="en-US" smtClean="0"/>
               <a:pPr/>
-              <a:t>21</a:t>
+              <a:t>22</a:t>
             </a:fld>
             <a:endParaRPr lang="en-US"/>
           </a:p>
@@ -12771,8 +13107,8 @@
         </p:nvSpPr>
         <p:spPr>
           <a:xfrm>
-            <a:off x="614856" y="1623849"/>
-            <a:ext cx="7857279" cy="1107996"/>
+            <a:off x="63063" y="1700208"/>
+            <a:ext cx="7902356" cy="769441"/>
           </a:xfrm>
           <a:prstGeom prst="rect">
             <a:avLst/>
@@ -12786,109 +13122,14 @@
           <a:lstStyle/>
           <a:p>
             <a:r>
-              <a:rPr lang="en-US" dirty="0"/>
-              <a:t>In 1000 documents each of 10 words suppose token “coffee” occurs 1000 times</a:t>
-            </a:r>
-            <a:endParaRPr lang="en-US" sz="2400" b="1" i="1" dirty="0"/>
+              <a:rPr lang="en-US" sz="2000" b="1" i="1" dirty="0"/>
+              <a:t>Coffee occurs 1 time in all documents, and each document is 1000 words.</a:t>
+            </a:r>
           </a:p>
           <a:p>
             <a:r>
               <a:rPr lang="en-US" sz="2400" b="1" i="1" dirty="0"/>
-              <a:t>TF = 1000 </a:t>
-            </a:r>
-            <a:r>
-              <a:rPr lang="en-US" sz="2400" b="1" i="1" dirty="0">
-                <a:solidFill>
-                  <a:srgbClr val="FF0000"/>
-                </a:solidFill>
-              </a:rPr>
-              <a:t>/ 10 </a:t>
-            </a:r>
-            <a:r>
-              <a:rPr lang="en-US" sz="1600" i="1" dirty="0"/>
-              <a:t>#normalizes to doc length</a:t>
-            </a:r>
-          </a:p>
-          <a:p>
-            <a:r>
-              <a:rPr lang="en-US" sz="2400" b="1" i="1" dirty="0"/>
-              <a:t>TF = 100</a:t>
-            </a:r>
-          </a:p>
-        </p:txBody>
-      </p:sp>
-      <p:sp>
-        <p:nvSpPr>
-          <p:cNvPr id="7" name="TextBox 6"/>
-          <p:cNvSpPr txBox="1"/>
-          <p:nvPr/>
-        </p:nvSpPr>
-        <p:spPr>
-          <a:xfrm>
-            <a:off x="614856" y="2993952"/>
-            <a:ext cx="2999539" cy="1200329"/>
-          </a:xfrm>
-          <a:prstGeom prst="rect">
-            <a:avLst/>
-          </a:prstGeom>
-          <a:noFill/>
-        </p:spPr>
-        <p:txBody>
-          <a:bodyPr wrap="none" rtlCol="0">
-            <a:spAutoFit/>
-          </a:bodyPr>
-          <a:lstStyle/>
-          <a:p>
-            <a:r>
-              <a:rPr lang="en-US" sz="2400" b="1" i="1" dirty="0"/>
-              <a:t>IDF = log(1000) / 1000</a:t>
-            </a:r>
-          </a:p>
-          <a:p>
-            <a:r>
-              <a:rPr lang="en-US" sz="2400" b="1" i="1" dirty="0"/>
-              <a:t>IDF = 6.9 /1000</a:t>
-            </a:r>
-          </a:p>
-          <a:p>
-            <a:r>
-              <a:rPr lang="en-US" sz="2400" b="1" i="1" dirty="0"/>
-              <a:t>IDF = .0069</a:t>
-            </a:r>
-          </a:p>
-        </p:txBody>
-      </p:sp>
-      <p:sp>
-        <p:nvSpPr>
-          <p:cNvPr id="9" name="TextBox 8"/>
-          <p:cNvSpPr txBox="1"/>
-          <p:nvPr/>
-        </p:nvSpPr>
-        <p:spPr>
-          <a:xfrm>
-            <a:off x="614856" y="4456387"/>
-            <a:ext cx="2811988" cy="830997"/>
-          </a:xfrm>
-          <a:prstGeom prst="rect">
-            <a:avLst/>
-          </a:prstGeom>
-          <a:noFill/>
-        </p:spPr>
-        <p:txBody>
-          <a:bodyPr wrap="none" rtlCol="0">
-            <a:spAutoFit/>
-          </a:bodyPr>
-          <a:lstStyle/>
-          <a:p>
-            <a:r>
-              <a:rPr lang="en-US" sz="2400" b="1" i="1" dirty="0"/>
-              <a:t>TF-IDF  = 100 * .0069</a:t>
-            </a:r>
-          </a:p>
-          <a:p>
-            <a:r>
-              <a:rPr lang="en-US" sz="2400" b="1" i="1" dirty="0"/>
-              <a:t>TF-IDF = .69</a:t>
+              <a:t>TF = 0.10</a:t>
             </a:r>
           </a:p>
         </p:txBody>
@@ -12936,7 +13177,7 @@
                 <a:ea typeface="Arial Unicode MS" panose="020B0604020202020204" pitchFamily="34" charset="-128"/>
                 <a:cs typeface="Arial Unicode MS" panose="020B0604020202020204" pitchFamily="34" charset="-128"/>
               </a:rPr>
-              <a:t>Coffee TF = 1000  will look VERY important but  TFIDF = 0.69 will correctly have minimal impact for analysis. </a:t>
+              <a:t>With simple word frequency “coffee” will be 1000 and look important.  But TF-IDF penalizes this.</a:t>
             </a:r>
             <a:endParaRPr lang="en-US" sz="1600" kern="1200" dirty="0">
               <a:solidFill>
@@ -12957,8 +13198,8 @@
         </p:nvSpPr>
         <p:spPr>
           <a:xfrm>
-            <a:off x="5224811" y="4828338"/>
-            <a:ext cx="3703699" cy="725214"/>
+            <a:off x="5555764" y="3663138"/>
+            <a:ext cx="3086097" cy="725214"/>
           </a:xfrm>
           <a:prstGeom prst="rect">
             <a:avLst/>
@@ -12993,7 +13234,7 @@
             <a:pPr algn="ctr"/>
             <a:r>
               <a:rPr lang="en-US" sz="1600" dirty="0"/>
-              <a:t>*Caveat – the results in R are normalized/scaled by default &amp; document lengths are not the same .</a:t>
+              <a:t>Log 1 = 0</a:t>
             </a:r>
           </a:p>
         </p:txBody>
@@ -13086,10 +13327,98 @@
       </p:cxnSp>
       <p:sp>
         <p:nvSpPr>
-          <p:cNvPr id="13" name="Rectangular Callout 12">
+          <p:cNvPr id="15" name="TextBox 14">
             <a:extLst>
               <a:ext uri="{FF2B5EF4-FFF2-40B4-BE49-F238E27FC236}">
-                <a16:creationId xmlns:a16="http://schemas.microsoft.com/office/drawing/2014/main" id="{47F79CBE-D204-7CC3-C45D-4638E1124630}"/>
+                <a16:creationId xmlns:a16="http://schemas.microsoft.com/office/drawing/2014/main" id="{B4CD0BD9-535F-8CC1-EF84-CEF8AB06B7A4}"/>
+              </a:ext>
+            </a:extLst>
+          </p:cNvPr>
+          <p:cNvSpPr txBox="1"/>
+          <p:nvPr/>
+        </p:nvSpPr>
+        <p:spPr>
+          <a:xfrm>
+            <a:off x="80577" y="3750083"/>
+            <a:ext cx="5345566" cy="707886"/>
+          </a:xfrm>
+          <a:prstGeom prst="rect">
+            <a:avLst/>
+          </a:prstGeom>
+          <a:noFill/>
+        </p:spPr>
+        <p:txBody>
+          <a:bodyPr wrap="none" rtlCol="0">
+            <a:spAutoFit/>
+          </a:bodyPr>
+          <a:lstStyle/>
+          <a:p>
+            <a:r>
+              <a:rPr lang="en-US" sz="2000" b="1" i="1" dirty="0"/>
+              <a:t>Coffee occurs across all documents in the corpus.</a:t>
+            </a:r>
+          </a:p>
+          <a:p>
+            <a:r>
+              <a:rPr lang="en-US" sz="2000" b="1" i="1" dirty="0"/>
+              <a:t>IDF = 0</a:t>
+            </a:r>
+          </a:p>
+        </p:txBody>
+      </p:sp>
+      <p:sp>
+        <p:nvSpPr>
+          <p:cNvPr id="16" name="TextBox 15">
+            <a:extLst>
+              <a:ext uri="{FF2B5EF4-FFF2-40B4-BE49-F238E27FC236}">
+                <a16:creationId xmlns:a16="http://schemas.microsoft.com/office/drawing/2014/main" id="{EEE71AEC-1C7B-D735-C4A0-4BA2C0BC5B48}"/>
+              </a:ext>
+            </a:extLst>
+          </p:cNvPr>
+          <p:cNvSpPr txBox="1"/>
+          <p:nvPr/>
+        </p:nvSpPr>
+        <p:spPr>
+          <a:xfrm>
+            <a:off x="80577" y="4984170"/>
+            <a:ext cx="5345566" cy="1015663"/>
+          </a:xfrm>
+          <a:prstGeom prst="rect">
+            <a:avLst/>
+          </a:prstGeom>
+          <a:noFill/>
+        </p:spPr>
+        <p:txBody>
+          <a:bodyPr wrap="none" rtlCol="0">
+            <a:spAutoFit/>
+          </a:bodyPr>
+          <a:lstStyle/>
+          <a:p>
+            <a:r>
+              <a:rPr lang="en-US" sz="2000" b="1" i="1" dirty="0"/>
+              <a:t>Coffee occurs across all documents in the corpus.</a:t>
+            </a:r>
+          </a:p>
+          <a:p>
+            <a:r>
+              <a:rPr lang="en-US" sz="2000" b="1" i="1" dirty="0"/>
+              <a:t>TF*IDF = 0.10*0</a:t>
+            </a:r>
+          </a:p>
+          <a:p>
+            <a:r>
+              <a:rPr lang="en-US" sz="2000" b="1" i="1" dirty="0"/>
+              <a:t>TF*IDF = 0</a:t>
+            </a:r>
+          </a:p>
+        </p:txBody>
+      </p:sp>
+      <p:sp>
+        <p:nvSpPr>
+          <p:cNvPr id="17" name="Rectangle 16">
+            <a:extLst>
+              <a:ext uri="{FF2B5EF4-FFF2-40B4-BE49-F238E27FC236}">
+                <a16:creationId xmlns:a16="http://schemas.microsoft.com/office/drawing/2014/main" id="{386A5FD1-370E-72AA-C441-EF8018EC566A}"/>
               </a:ext>
             </a:extLst>
           </p:cNvPr>
@@ -13098,20 +13427,23 @@
         </p:nvSpPr>
         <p:spPr>
           <a:xfrm>
-            <a:off x="5197890" y="2935545"/>
-            <a:ext cx="3703699" cy="1798296"/>
-          </a:xfrm>
-          <a:prstGeom prst="wedgeRectCallout">
-            <a:avLst>
-              <a:gd name="adj1" fmla="val -123833"/>
-              <a:gd name="adj2" fmla="val -25147"/>
-            </a:avLst>
+            <a:off x="5524748" y="2068182"/>
+            <a:ext cx="3117113" cy="725214"/>
+          </a:xfrm>
+          <a:prstGeom prst="rect">
+            <a:avLst/>
           </a:prstGeom>
+          <a:solidFill>
+            <a:srgbClr val="FFC000"/>
+          </a:solidFill>
+          <a:ln>
+            <a:noFill/>
+          </a:ln>
         </p:spPr>
         <p:style>
           <a:lnRef idx="2">
             <a:schemeClr val="accent1">
-              <a:shade val="15000"/>
+              <a:shade val="50000"/>
             </a:schemeClr>
           </a:lnRef>
           <a:fillRef idx="1">
@@ -13129,79 +13461,64 @@
           <a:lstStyle/>
           <a:p>
             <a:pPr algn="ctr"/>
-            <a:endParaRPr lang="en-US"/>
+            <a:r>
+              <a:rPr lang="en-US" sz="1600" dirty="0"/>
+              <a:t>Coffee accounts for 10% of the unique terms.</a:t>
+            </a:r>
           </a:p>
         </p:txBody>
       </p:sp>
       <p:sp>
         <p:nvSpPr>
-          <p:cNvPr id="14" name="TextBox 13">
+          <p:cNvPr id="18" name="Rectangle 17">
             <a:extLst>
               <a:ext uri="{FF2B5EF4-FFF2-40B4-BE49-F238E27FC236}">
-                <a16:creationId xmlns:a16="http://schemas.microsoft.com/office/drawing/2014/main" id="{E140EA7F-7648-A9B2-F11D-60A9C8104CE6}"/>
+                <a16:creationId xmlns:a16="http://schemas.microsoft.com/office/drawing/2014/main" id="{39C17897-1285-EBD7-E4EB-2F1C3B88E277}"/>
               </a:ext>
             </a:extLst>
           </p:cNvPr>
-          <p:cNvSpPr txBox="1"/>
+          <p:cNvSpPr/>
           <p:nvPr/>
         </p:nvSpPr>
         <p:spPr>
           <a:xfrm>
-            <a:off x="5270780" y="2970505"/>
-            <a:ext cx="2832213" cy="1569660"/>
+            <a:off x="5524748" y="5129394"/>
+            <a:ext cx="3086097" cy="725214"/>
           </a:xfrm>
           <a:prstGeom prst="rect">
             <a:avLst/>
           </a:prstGeom>
-          <a:noFill/>
+          <a:solidFill>
+            <a:srgbClr val="FFC000"/>
+          </a:solidFill>
+          <a:ln>
+            <a:noFill/>
+          </a:ln>
         </p:spPr>
+        <p:style>
+          <a:lnRef idx="2">
+            <a:schemeClr val="accent1">
+              <a:shade val="50000"/>
+            </a:schemeClr>
+          </a:lnRef>
+          <a:fillRef idx="1">
+            <a:schemeClr val="accent1"/>
+          </a:fillRef>
+          <a:effectRef idx="0">
+            <a:schemeClr val="accent1"/>
+          </a:effectRef>
+          <a:fontRef idx="minor">
+            <a:schemeClr val="lt1"/>
+          </a:fontRef>
+        </p:style>
         <p:txBody>
-          <a:bodyPr wrap="square" rtlCol="0">
-            <a:spAutoFit/>
-          </a:bodyPr>
+          <a:bodyPr rtlCol="0" anchor="ctr"/>
           <a:lstStyle/>
           <a:p>
-            <a:r>
-              <a:rPr lang="en-US" sz="1200" dirty="0">
-                <a:solidFill>
-                  <a:schemeClr val="bg1"/>
-                </a:solidFill>
-              </a:rPr>
-              <a:t>log base 10 is the number of times a number is needed to be multiplied to reach the number [10*10*10=1000]</a:t>
-            </a:r>
-          </a:p>
-          <a:p>
-            <a:endParaRPr lang="en-US" sz="1200" dirty="0">
-              <a:solidFill>
-                <a:schemeClr val="bg1"/>
-              </a:solidFill>
-            </a:endParaRPr>
-          </a:p>
-          <a:p>
-            <a:r>
-              <a:rPr lang="en-US" sz="1200" dirty="0">
-                <a:solidFill>
-                  <a:schemeClr val="bg1"/>
-                </a:solidFill>
-              </a:rPr>
-              <a:t>DEFAULT in tm is to use Euler’s Number (natural log) 2.718</a:t>
-            </a:r>
-          </a:p>
-          <a:p>
-            <a:endParaRPr lang="en-US" sz="1200" dirty="0">
-              <a:solidFill>
-                <a:schemeClr val="bg1"/>
-              </a:solidFill>
-            </a:endParaRPr>
-          </a:p>
-          <a:p>
-            <a:r>
-              <a:rPr lang="en-US" sz="1200" dirty="0">
-                <a:solidFill>
-                  <a:schemeClr val="bg1"/>
-                </a:solidFill>
-              </a:rPr>
-              <a:t>So e^6.91  is ~1000</a:t>
+            <a:pPr algn="ctr"/>
+            <a:r>
+              <a:rPr lang="en-US" sz="1600" dirty="0"/>
+              <a:t>TF IDF has a value of 0, ”coffee” has no novelty or insight.</a:t>
             </a:r>
           </a:p>
         </p:txBody>
@@ -13250,7 +13567,7 @@
                                           </p:stCondLst>
                                         </p:cTn>
                                         <p:tgtEl>
-                                          <p:spTgt spid="7"/>
+                                          <p:spTgt spid="8"/>
                                         </p:tgtEl>
                                         <p:attrNameLst>
                                           <p:attrName>style.visibility</p:attrName>
@@ -13295,7 +13612,7 @@
                                           </p:stCondLst>
                                         </p:cTn>
                                         <p:tgtEl>
-                                          <p:spTgt spid="9"/>
+                                          <p:spTgt spid="10"/>
                                         </p:tgtEl>
                                         <p:attrNameLst>
                                           <p:attrName>style.visibility</p:attrName>
@@ -13340,7 +13657,7 @@
                                           </p:stCondLst>
                                         </p:cTn>
                                         <p:tgtEl>
-                                          <p:spTgt spid="8"/>
+                                          <p:spTgt spid="17"/>
                                         </p:tgtEl>
                                         <p:attrNameLst>
                                           <p:attrName>style.visibility</p:attrName>
@@ -13385,7 +13702,7 @@
                                           </p:stCondLst>
                                         </p:cTn>
                                         <p:tgtEl>
-                                          <p:spTgt spid="10"/>
+                                          <p:spTgt spid="18"/>
                                         </p:tgtEl>
                                         <p:attrNameLst>
                                           <p:attrName>style.visibility</p:attrName>
@@ -13426,16 +13743,16 @@
       </p:par>
     </p:tnLst>
     <p:bldLst>
-      <p:bldP spid="7" grpId="0"/>
-      <p:bldP spid="9" grpId="0"/>
       <p:bldP spid="10" grpId="0" animBg="1"/>
       <p:bldP spid="8" grpId="0" animBg="1"/>
+      <p:bldP spid="17" grpId="0" animBg="1"/>
+      <p:bldP spid="18" grpId="0" animBg="1"/>
     </p:bldLst>
   </p:timing>
 </p:sld>
 </file>
 
-<file path=ppt/slides/slide22.xml><?xml version="1.0" encoding="utf-8"?>
+<file path=ppt/slides/slide23.xml><?xml version="1.0" encoding="utf-8"?>
 <p:sld xmlns:a="http://schemas.openxmlformats.org/drawingml/2006/main" xmlns:r="http://schemas.openxmlformats.org/officeDocument/2006/relationships" xmlns:p="http://schemas.openxmlformats.org/presentationml/2006/main">
   <p:cSld>
     <p:spTree>
@@ -13470,7 +13787,7 @@
             <a:fld id="{6700A58B-DD98-43D0-B791-721480A02982}" type="datetime1">
               <a:rPr lang="en-US" smtClean="0"/>
               <a:pPr/>
-              <a:t>4/28/25</a:t>
+              <a:t>4/20/26</a:t>
             </a:fld>
             <a:endParaRPr lang="en-US"/>
           </a:p>
@@ -13647,7 +13964,7 @@
             <a:fld id="{37290FF7-652B-4475-AEAB-8B1A5D23AE09}" type="slidenum">
               <a:rPr lang="en-US" smtClean="0"/>
               <a:pPr/>
-              <a:t>22</a:t>
+              <a:t>23</a:t>
             </a:fld>
             <a:endParaRPr lang="en-US"/>
           </a:p>
@@ -14156,7 +14473,7 @@
 </p:sld>
 </file>
 
-<file path=ppt/slides/slide23.xml><?xml version="1.0" encoding="utf-8"?>
+<file path=ppt/slides/slide24.xml><?xml version="1.0" encoding="utf-8"?>
 <p:sld xmlns:a="http://schemas.openxmlformats.org/drawingml/2006/main" xmlns:r="http://schemas.openxmlformats.org/officeDocument/2006/relationships" xmlns:p="http://schemas.openxmlformats.org/presentationml/2006/main">
   <p:cSld>
     <p:spTree>
@@ -14191,7 +14508,7 @@
             <a:fld id="{6700A58B-DD98-43D0-B791-721480A02982}" type="datetime1">
               <a:rPr lang="en-US" smtClean="0"/>
               <a:pPr/>
-              <a:t>4/28/25</a:t>
+              <a:t>4/20/26</a:t>
             </a:fld>
             <a:endParaRPr lang="en-US"/>
           </a:p>
@@ -14368,7 +14685,7 @@
             <a:fld id="{37290FF7-652B-4475-AEAB-8B1A5D23AE09}" type="slidenum">
               <a:rPr lang="en-US" smtClean="0"/>
               <a:pPr/>
-              <a:t>23</a:t>
+              <a:t>24</a:t>
             </a:fld>
             <a:endParaRPr lang="en-US"/>
           </a:p>
@@ -15052,7 +15369,7 @@
 </p:sld>
 </file>
 
-<file path=ppt/slides/slide24.xml><?xml version="1.0" encoding="utf-8"?>
+<file path=ppt/slides/slide25.xml><?xml version="1.0" encoding="utf-8"?>
 <p:sld xmlns:a="http://schemas.openxmlformats.org/drawingml/2006/main" xmlns:r="http://schemas.openxmlformats.org/officeDocument/2006/relationships" xmlns:p="http://schemas.openxmlformats.org/presentationml/2006/main">
   <p:cSld>
     <p:spTree>
@@ -15087,7 +15404,7 @@
             <a:fld id="{6700A58B-DD98-43D0-B791-721480A02982}" type="datetime1">
               <a:rPr lang="en-US" smtClean="0"/>
               <a:pPr/>
-              <a:t>4/28/25</a:t>
+              <a:t>4/20/26</a:t>
             </a:fld>
             <a:endParaRPr lang="en-US"/>
           </a:p>
@@ -15264,7 +15581,7 @@
             <a:fld id="{37290FF7-652B-4475-AEAB-8B1A5D23AE09}" type="slidenum">
               <a:rPr lang="en-US" smtClean="0"/>
               <a:pPr/>
-              <a:t>24</a:t>
+              <a:t>25</a:t>
             </a:fld>
             <a:endParaRPr lang="en-US"/>
           </a:p>
@@ -15552,7 +15869,7 @@
             <a:fld id="{6700A58B-DD98-43D0-B791-721480A02982}" type="datetime1">
               <a:rPr lang="en-US" smtClean="0"/>
               <a:pPr/>
-              <a:t>4/28/25</a:t>
+              <a:t>4/20/26</a:t>
             </a:fld>
             <a:endParaRPr lang="en-US"/>
           </a:p>
@@ -16429,7 +16746,7 @@
             <a:fld id="{6700A58B-DD98-43D0-B791-721480A02982}" type="datetime1">
               <a:rPr lang="en-US" smtClean="0"/>
               <a:pPr/>
-              <a:t>4/28/25</a:t>
+              <a:t>4/20/26</a:t>
             </a:fld>
             <a:endParaRPr lang="en-US"/>
           </a:p>
@@ -19717,7 +20034,7 @@
             <a:fld id="{6700A58B-DD98-43D0-B791-721480A02982}" type="datetime1">
               <a:rPr lang="en-US" smtClean="0"/>
               <a:pPr/>
-              <a:t>4/28/25</a:t>
+              <a:t>4/20/26</a:t>
             </a:fld>
             <a:endParaRPr lang="en-US"/>
           </a:p>
@@ -20776,7 +21093,7 @@
             <a:fld id="{6700A58B-DD98-43D0-B791-721480A02982}" type="datetime1">
               <a:rPr lang="en-US" smtClean="0"/>
               <a:pPr/>
-              <a:t>4/28/25</a:t>
+              <a:t>4/20/26</a:t>
             </a:fld>
             <a:endParaRPr lang="en-US"/>
           </a:p>

</xml_diff>